<commit_message>
supp info and new synechococcus papers
</commit_message>
<xml_diff>
--- a/doc/intro to kg 10032026.pptx
+++ b/doc/intro to kg 10032026.pptx
@@ -7,6 +7,8 @@
   <p:sldIdLst>
     <p:sldId id="256" r:id="rId2"/>
     <p:sldId id="257" r:id="rId3"/>
+    <p:sldId id="258" r:id="rId4"/>
+    <p:sldId id="259" r:id="rId5"/>
   </p:sldIdLst>
   <p:sldSz cx="12192000" cy="6858000"/>
   <p:notesSz cx="6858000" cy="9144000"/>
@@ -105,6 +107,11 @@
       </a:defRPr>
     </a:lvl9pPr>
   </p:defaultTextStyle>
+  <p:extLst>
+    <p:ext uri="{EFAFB233-063F-42B5-8137-9DF3F51BA10A}">
+      <p15:sldGuideLst xmlns:p15="http://schemas.microsoft.com/office/powerpoint/2012/main"/>
+    </p:ext>
+  </p:extLst>
 </p:presentation>
 </file>
 
@@ -257,7 +264,7 @@
           <a:p>
             <a:fld id="{032C3F86-8010-4C64-B140-5734EAE17AEB}" type="datetimeFigureOut">
               <a:rPr lang="en-IL" smtClean="0"/>
-              <a:t>10/03/2026</a:t>
+              <a:t>15/03/2026</a:t>
             </a:fld>
             <a:endParaRPr lang="en-IL"/>
           </a:p>
@@ -457,7 +464,7 @@
           <a:p>
             <a:fld id="{032C3F86-8010-4C64-B140-5734EAE17AEB}" type="datetimeFigureOut">
               <a:rPr lang="en-IL" smtClean="0"/>
-              <a:t>10/03/2026</a:t>
+              <a:t>15/03/2026</a:t>
             </a:fld>
             <a:endParaRPr lang="en-IL"/>
           </a:p>
@@ -667,7 +674,7 @@
           <a:p>
             <a:fld id="{032C3F86-8010-4C64-B140-5734EAE17AEB}" type="datetimeFigureOut">
               <a:rPr lang="en-IL" smtClean="0"/>
-              <a:t>10/03/2026</a:t>
+              <a:t>15/03/2026</a:t>
             </a:fld>
             <a:endParaRPr lang="en-IL"/>
           </a:p>
@@ -867,7 +874,7 @@
           <a:p>
             <a:fld id="{032C3F86-8010-4C64-B140-5734EAE17AEB}" type="datetimeFigureOut">
               <a:rPr lang="en-IL" smtClean="0"/>
-              <a:t>10/03/2026</a:t>
+              <a:t>15/03/2026</a:t>
             </a:fld>
             <a:endParaRPr lang="en-IL"/>
           </a:p>
@@ -1143,7 +1150,7 @@
           <a:p>
             <a:fld id="{032C3F86-8010-4C64-B140-5734EAE17AEB}" type="datetimeFigureOut">
               <a:rPr lang="en-IL" smtClean="0"/>
-              <a:t>10/03/2026</a:t>
+              <a:t>15/03/2026</a:t>
             </a:fld>
             <a:endParaRPr lang="en-IL"/>
           </a:p>
@@ -1411,7 +1418,7 @@
           <a:p>
             <a:fld id="{032C3F86-8010-4C64-B140-5734EAE17AEB}" type="datetimeFigureOut">
               <a:rPr lang="en-IL" smtClean="0"/>
-              <a:t>10/03/2026</a:t>
+              <a:t>15/03/2026</a:t>
             </a:fld>
             <a:endParaRPr lang="en-IL"/>
           </a:p>
@@ -1826,7 +1833,7 @@
           <a:p>
             <a:fld id="{032C3F86-8010-4C64-B140-5734EAE17AEB}" type="datetimeFigureOut">
               <a:rPr lang="en-IL" smtClean="0"/>
-              <a:t>10/03/2026</a:t>
+              <a:t>15/03/2026</a:t>
             </a:fld>
             <a:endParaRPr lang="en-IL"/>
           </a:p>
@@ -1968,7 +1975,7 @@
           <a:p>
             <a:fld id="{032C3F86-8010-4C64-B140-5734EAE17AEB}" type="datetimeFigureOut">
               <a:rPr lang="en-IL" smtClean="0"/>
-              <a:t>10/03/2026</a:t>
+              <a:t>15/03/2026</a:t>
             </a:fld>
             <a:endParaRPr lang="en-IL"/>
           </a:p>
@@ -2081,7 +2088,7 @@
           <a:p>
             <a:fld id="{032C3F86-8010-4C64-B140-5734EAE17AEB}" type="datetimeFigureOut">
               <a:rPr lang="en-IL" smtClean="0"/>
-              <a:t>10/03/2026</a:t>
+              <a:t>15/03/2026</a:t>
             </a:fld>
             <a:endParaRPr lang="en-IL"/>
           </a:p>
@@ -2394,7 +2401,7 @@
           <a:p>
             <a:fld id="{032C3F86-8010-4C64-B140-5734EAE17AEB}" type="datetimeFigureOut">
               <a:rPr lang="en-IL" smtClean="0"/>
-              <a:t>10/03/2026</a:t>
+              <a:t>15/03/2026</a:t>
             </a:fld>
             <a:endParaRPr lang="en-IL"/>
           </a:p>
@@ -2683,7 +2690,7 @@
           <a:p>
             <a:fld id="{032C3F86-8010-4C64-B140-5734EAE17AEB}" type="datetimeFigureOut">
               <a:rPr lang="en-IL" smtClean="0"/>
-              <a:t>10/03/2026</a:t>
+              <a:t>15/03/2026</a:t>
             </a:fld>
             <a:endParaRPr lang="en-IL"/>
           </a:p>
@@ -2926,7 +2933,7 @@
           <a:p>
             <a:fld id="{032C3F86-8010-4C64-B140-5734EAE17AEB}" type="datetimeFigureOut">
               <a:rPr lang="en-IL" smtClean="0"/>
-              <a:t>10/03/2026</a:t>
+              <a:t>15/03/2026</a:t>
             </a:fld>
             <a:endParaRPr lang="en-IL"/>
           </a:p>
@@ -4597,6 +4604,375 @@
     <p:extLst>
       <p:ext uri="{BB962C8B-B14F-4D97-AF65-F5344CB8AC3E}">
         <p14:creationId xmlns:p14="http://schemas.microsoft.com/office/powerpoint/2010/main" val="3602576075"/>
+      </p:ext>
+    </p:extLst>
+  </p:cSld>
+  <p:clrMapOvr>
+    <a:masterClrMapping/>
+  </p:clrMapOvr>
+</p:sld>
+</file>
+
+<file path=ppt/slides/slide3.xml><?xml version="1.0" encoding="utf-8"?>
+<p:sld xmlns:a="http://schemas.openxmlformats.org/drawingml/2006/main" xmlns:r="http://schemas.openxmlformats.org/officeDocument/2006/relationships" xmlns:p="http://schemas.openxmlformats.org/presentationml/2006/main">
+  <p:cSld>
+    <p:spTree>
+      <p:nvGrpSpPr>
+        <p:cNvPr id="1" name=""/>
+        <p:cNvGrpSpPr/>
+        <p:nvPr/>
+      </p:nvGrpSpPr>
+      <p:grpSpPr>
+        <a:xfrm>
+          <a:off x="0" y="0"/>
+          <a:ext cx="0" cy="0"/>
+          <a:chOff x="0" y="0"/>
+          <a:chExt cx="0" cy="0"/>
+        </a:xfrm>
+      </p:grpSpPr>
+      <p:sp>
+        <p:nvSpPr>
+          <p:cNvPr id="4" name="Title 3">
+            <a:extLst>
+              <a:ext uri="{FF2B5EF4-FFF2-40B4-BE49-F238E27FC236}">
+                <a16:creationId xmlns:a16="http://schemas.microsoft.com/office/drawing/2014/main" id="{FB602867-2EDF-E54A-3B02-9FB402E82EA9}"/>
+              </a:ext>
+            </a:extLst>
+          </p:cNvPr>
+          <p:cNvSpPr>
+            <a:spLocks noGrp="1"/>
+          </p:cNvSpPr>
+          <p:nvPr>
+            <p:ph type="title"/>
+          </p:nvPr>
+        </p:nvSpPr>
+        <p:spPr/>
+        <p:txBody>
+          <a:bodyPr/>
+          <a:lstStyle/>
+          <a:p>
+            <a:endParaRPr lang="en-IL"/>
+          </a:p>
+        </p:txBody>
+      </p:sp>
+      <p:sp>
+        <p:nvSpPr>
+          <p:cNvPr id="5" name="Content Placeholder 4">
+            <a:extLst>
+              <a:ext uri="{FF2B5EF4-FFF2-40B4-BE49-F238E27FC236}">
+                <a16:creationId xmlns:a16="http://schemas.microsoft.com/office/drawing/2014/main" id="{4259F801-BFE6-5D2B-3254-4D9E05E88108}"/>
+              </a:ext>
+            </a:extLst>
+          </p:cNvPr>
+          <p:cNvSpPr>
+            <a:spLocks noGrp="1"/>
+          </p:cNvSpPr>
+          <p:nvPr>
+            <p:ph sz="half" idx="1"/>
+          </p:nvPr>
+        </p:nvSpPr>
+        <p:spPr/>
+        <p:txBody>
+          <a:bodyPr>
+            <a:normAutofit lnSpcReduction="10000"/>
+          </a:bodyPr>
+          <a:lstStyle/>
+          <a:p>
+            <a:r>
+              <a:rPr lang="en-US" dirty="0"/>
+              <a:t>Kg</a:t>
+            </a:r>
+          </a:p>
+          <a:p>
+            <a:r>
+              <a:rPr lang="en-US" dirty="0"/>
+              <a:t>Analysis</a:t>
+            </a:r>
+          </a:p>
+          <a:p>
+            <a:r>
+              <a:rPr lang="en-US" b="1" dirty="0"/>
+              <a:t>How I tackle</a:t>
+            </a:r>
+          </a:p>
+          <a:p>
+            <a:r>
+              <a:rPr lang="en-US" dirty="0"/>
+              <a:t>Biological question </a:t>
+            </a:r>
+            <a:r>
+              <a:rPr lang="en-US" dirty="0">
+                <a:sym typeface="Wingdings" panose="05000000000000000000" pitchFamily="2" charset="2"/>
+              </a:rPr>
+              <a:t> insights </a:t>
+            </a:r>
+          </a:p>
+          <a:p>
+            <a:r>
+              <a:rPr lang="en-US" dirty="0">
+                <a:sym typeface="Wingdings" panose="05000000000000000000" pitchFamily="2" charset="2"/>
+              </a:rPr>
+              <a:t>Research question  conclusion  </a:t>
+            </a:r>
+            <a:endParaRPr lang="en-US" dirty="0"/>
+          </a:p>
+          <a:p>
+            <a:r>
+              <a:rPr lang="en-US" dirty="0"/>
+              <a:t>…</a:t>
+            </a:r>
+          </a:p>
+          <a:p>
+            <a:r>
+              <a:rPr lang="en-US" dirty="0"/>
+              <a:t>Example</a:t>
+            </a:r>
+          </a:p>
+          <a:p>
+            <a:pPr lvl="1"/>
+            <a:r>
+              <a:rPr lang="en-US" dirty="0"/>
+              <a:t>Summary</a:t>
+            </a:r>
+          </a:p>
+          <a:p>
+            <a:pPr lvl="1"/>
+            <a:r>
+              <a:rPr lang="en-US" dirty="0"/>
+              <a:t>How</a:t>
+            </a:r>
+          </a:p>
+          <a:p>
+            <a:pPr lvl="1"/>
+            <a:endParaRPr lang="en-IL" dirty="0"/>
+          </a:p>
+        </p:txBody>
+      </p:sp>
+      <p:sp>
+        <p:nvSpPr>
+          <p:cNvPr id="6" name="Content Placeholder 5">
+            <a:extLst>
+              <a:ext uri="{FF2B5EF4-FFF2-40B4-BE49-F238E27FC236}">
+                <a16:creationId xmlns:a16="http://schemas.microsoft.com/office/drawing/2014/main" id="{9054F2ED-910F-E045-D80F-A2B0DB72AC1D}"/>
+              </a:ext>
+            </a:extLst>
+          </p:cNvPr>
+          <p:cNvSpPr>
+            <a:spLocks noGrp="1"/>
+          </p:cNvSpPr>
+          <p:nvPr>
+            <p:ph sz="half" idx="2"/>
+          </p:nvPr>
+        </p:nvSpPr>
+        <p:spPr/>
+        <p:txBody>
+          <a:bodyPr>
+            <a:normAutofit lnSpcReduction="10000"/>
+          </a:bodyPr>
+          <a:lstStyle/>
+          <a:p>
+            <a:r>
+              <a:rPr lang="en-US" dirty="0" err="1"/>
+              <a:t>Prochlorococous</a:t>
+            </a:r>
+            <a:r>
+              <a:rPr lang="en-US" dirty="0"/>
+              <a:t>/Alteromonas</a:t>
+            </a:r>
+          </a:p>
+          <a:p>
+            <a:r>
+              <a:rPr lang="en-US" dirty="0"/>
+              <a:t>4 mechanisms</a:t>
+            </a:r>
+          </a:p>
+          <a:p>
+            <a:pPr lvl="1"/>
+            <a:r>
+              <a:rPr lang="en-US" dirty="0"/>
+              <a:t>1</a:t>
+            </a:r>
+          </a:p>
+          <a:p>
+            <a:pPr lvl="1"/>
+            <a:r>
+              <a:rPr lang="en-US" dirty="0"/>
+              <a:t>2</a:t>
+            </a:r>
+          </a:p>
+          <a:p>
+            <a:pPr lvl="1"/>
+            <a:r>
+              <a:rPr lang="en-US" dirty="0"/>
+              <a:t>3</a:t>
+            </a:r>
+          </a:p>
+          <a:p>
+            <a:pPr lvl="1"/>
+            <a:r>
+              <a:rPr lang="en-US" dirty="0"/>
+              <a:t>4</a:t>
+            </a:r>
+          </a:p>
+          <a:p>
+            <a:r>
+              <a:rPr lang="en-US" dirty="0"/>
+              <a:t>Conclusion</a:t>
+            </a:r>
+          </a:p>
+          <a:p>
+            <a:r>
+              <a:rPr lang="en-US" dirty="0"/>
+              <a:t>methods</a:t>
+            </a:r>
+            <a:endParaRPr lang="en-IL" dirty="0"/>
+          </a:p>
+        </p:txBody>
+      </p:sp>
+    </p:spTree>
+    <p:extLst>
+      <p:ext uri="{BB962C8B-B14F-4D97-AF65-F5344CB8AC3E}">
+        <p14:creationId xmlns:p14="http://schemas.microsoft.com/office/powerpoint/2010/main" val="456522413"/>
+      </p:ext>
+    </p:extLst>
+  </p:cSld>
+  <p:clrMapOvr>
+    <a:masterClrMapping/>
+  </p:clrMapOvr>
+</p:sld>
+</file>
+
+<file path=ppt/slides/slide4.xml><?xml version="1.0" encoding="utf-8"?>
+<p:sld xmlns:a="http://schemas.openxmlformats.org/drawingml/2006/main" xmlns:r="http://schemas.openxmlformats.org/officeDocument/2006/relationships" xmlns:p="http://schemas.openxmlformats.org/presentationml/2006/main">
+  <p:cSld>
+    <p:spTree>
+      <p:nvGrpSpPr>
+        <p:cNvPr id="1" name=""/>
+        <p:cNvGrpSpPr/>
+        <p:nvPr/>
+      </p:nvGrpSpPr>
+      <p:grpSpPr>
+        <a:xfrm>
+          <a:off x="0" y="0"/>
+          <a:ext cx="0" cy="0"/>
+          <a:chOff x="0" y="0"/>
+          <a:chExt cx="0" cy="0"/>
+        </a:xfrm>
+      </p:grpSpPr>
+      <p:sp>
+        <p:nvSpPr>
+          <p:cNvPr id="5" name="Title 4">
+            <a:extLst>
+              <a:ext uri="{FF2B5EF4-FFF2-40B4-BE49-F238E27FC236}">
+                <a16:creationId xmlns:a16="http://schemas.microsoft.com/office/drawing/2014/main" id="{A522460E-9C40-CB85-9DE8-08D787A1017B}"/>
+              </a:ext>
+            </a:extLst>
+          </p:cNvPr>
+          <p:cNvSpPr>
+            <a:spLocks noGrp="1"/>
+          </p:cNvSpPr>
+          <p:nvPr>
+            <p:ph type="title"/>
+          </p:nvPr>
+        </p:nvSpPr>
+        <p:spPr/>
+        <p:txBody>
+          <a:bodyPr/>
+          <a:lstStyle/>
+          <a:p>
+            <a:endParaRPr lang="en-IL"/>
+          </a:p>
+        </p:txBody>
+      </p:sp>
+      <p:sp>
+        <p:nvSpPr>
+          <p:cNvPr id="6" name="Content Placeholder 5">
+            <a:extLst>
+              <a:ext uri="{FF2B5EF4-FFF2-40B4-BE49-F238E27FC236}">
+                <a16:creationId xmlns:a16="http://schemas.microsoft.com/office/drawing/2014/main" id="{AF1F4FB0-95F4-D96F-DF61-FB3575E0C633}"/>
+              </a:ext>
+            </a:extLst>
+          </p:cNvPr>
+          <p:cNvSpPr>
+            <a:spLocks noGrp="1"/>
+          </p:cNvSpPr>
+          <p:nvPr>
+            <p:ph idx="1"/>
+          </p:nvPr>
+        </p:nvSpPr>
+        <p:spPr/>
+        <p:txBody>
+          <a:bodyPr/>
+          <a:lstStyle/>
+          <a:p>
+            <a:r>
+              <a:rPr lang="en-US" dirty="0"/>
+              <a:t>4 mechanism of interaction</a:t>
+            </a:r>
+          </a:p>
+          <a:p>
+            <a:r>
+              <a:rPr lang="en-US" dirty="0"/>
+              <a:t>Prochlorococcus/</a:t>
+            </a:r>
+            <a:r>
+              <a:rPr lang="en-US" dirty="0" err="1"/>
+              <a:t>synechococcus</a:t>
+            </a:r>
+            <a:r>
+              <a:rPr lang="en-US" dirty="0"/>
+              <a:t> interaction – consistency with studies in other organisms</a:t>
+            </a:r>
+          </a:p>
+          <a:p>
+            <a:r>
+              <a:rPr lang="en-US" dirty="0"/>
+              <a:t>Regulation? Hypotheticals? </a:t>
+            </a:r>
+          </a:p>
+          <a:p>
+            <a:r>
+              <a:rPr lang="en-US" dirty="0"/>
+              <a:t>RNA vs proteome</a:t>
+            </a:r>
+          </a:p>
+          <a:p>
+            <a:r>
+              <a:rPr lang="en-US" dirty="0"/>
+              <a:t>Prochlorococcus Axenic - death </a:t>
+            </a:r>
+          </a:p>
+          <a:p>
+            <a:pPr lvl="1"/>
+            <a:r>
+              <a:rPr lang="en-US" dirty="0"/>
+              <a:t>Proteome late</a:t>
+            </a:r>
+          </a:p>
+          <a:p>
+            <a:r>
+              <a:rPr lang="en-US" dirty="0"/>
+              <a:t>FBA?</a:t>
+            </a:r>
+          </a:p>
+          <a:p>
+            <a:endParaRPr lang="en-US" dirty="0"/>
+          </a:p>
+          <a:p>
+            <a:endParaRPr lang="en-US" dirty="0"/>
+          </a:p>
+          <a:p>
+            <a:endParaRPr lang="en-US" dirty="0"/>
+          </a:p>
+          <a:p>
+            <a:endParaRPr lang="en-IL" dirty="0"/>
+          </a:p>
+        </p:txBody>
+      </p:sp>
+    </p:spTree>
+    <p:extLst>
+      <p:ext uri="{BB962C8B-B14F-4D97-AF65-F5344CB8AC3E}">
+        <p14:creationId xmlns:p14="http://schemas.microsoft.com/office/powerpoint/2010/main" val="1615487069"/>
       </p:ext>
     </p:extLst>
   </p:cSld>

</xml_diff>